<commit_message>
Slides: titles in Arial instead of Oswald
Oswald isn't installed on most computers, so PowerPoint substituted a
font with uneven letter spacing. Arial ships everywhere.

Co-Authored-By: Claude Opus 5.5 <noreply@anthropic.com>
</commit_message>
<xml_diff>
--- a/docs/Rover Software for Teams.pptx
+++ b/docs/Rover Software for Teams.pptx
@@ -1786,9 +1786,9 @@
                 <a:solidFill>
                   <a:srgbClr val="15232B"/>
                 </a:solidFill>
-                <a:latin typeface="Oswald" pitchFamily="34" charset="0"/>
-                <a:ea typeface="Oswald" pitchFamily="34" charset="-122"/>
-                <a:cs typeface="Oswald" pitchFamily="34" charset="-120"/>
+                <a:latin typeface="Arial" pitchFamily="34" charset="0"/>
+                <a:ea typeface="Arial" pitchFamily="34" charset="-122"/>
+                <a:cs typeface="Arial" pitchFamily="34" charset="-120"/>
               </a:defRPr>
             </a:lvl1pPr>
           </a:lstStyle>
@@ -1914,9 +1914,9 @@
                 <a:solidFill>
                   <a:srgbClr val="15232B"/>
                 </a:solidFill>
-                <a:latin typeface="Oswald" pitchFamily="34" charset="0"/>
-                <a:ea typeface="Oswald" pitchFamily="34" charset="-122"/>
-                <a:cs typeface="Oswald" pitchFamily="34" charset="-120"/>
+                <a:latin typeface="Arial" pitchFamily="34" charset="0"/>
+                <a:ea typeface="Arial" pitchFamily="34" charset="-122"/>
+                <a:cs typeface="Arial" pitchFamily="34" charset="-120"/>
               </a:defRPr>
             </a:lvl1pPr>
           </a:lstStyle>
@@ -2320,9 +2320,9 @@
                 <a:solidFill>
                   <a:srgbClr val="F5F2EA"/>
                 </a:solidFill>
-                <a:latin typeface="Oswald" pitchFamily="34" charset="0"/>
-                <a:ea typeface="Oswald" pitchFamily="34" charset="-122"/>
-                <a:cs typeface="Oswald" pitchFamily="34" charset="-120"/>
+                <a:latin typeface="Arial" pitchFamily="34" charset="0"/>
+                <a:ea typeface="Arial" pitchFamily="34" charset="-122"/>
+                <a:cs typeface="Arial" pitchFamily="34" charset="-120"/>
               </a:rPr>
               <a:t>YOUR ROVER,</a:t>
             </a:r>
@@ -2340,9 +2340,9 @@
                 <a:solidFill>
                   <a:srgbClr val="F5F2EA"/>
                 </a:solidFill>
-                <a:latin typeface="Oswald" pitchFamily="34" charset="0"/>
-                <a:ea typeface="Oswald" pitchFamily="34" charset="-122"/>
-                <a:cs typeface="Oswald" pitchFamily="34" charset="-120"/>
+                <a:latin typeface="Arial" pitchFamily="34" charset="0"/>
+                <a:ea typeface="Arial" pitchFamily="34" charset="-122"/>
+                <a:cs typeface="Arial" pitchFamily="34" charset="-120"/>
               </a:rPr>
               <a:t>ON AUTOPILOT</a:t>
             </a:r>
@@ -2462,9 +2462,9 @@
                 <a:solidFill>
                   <a:srgbClr val="15232B"/>
                 </a:solidFill>
-                <a:latin typeface="Oswald" pitchFamily="34" charset="0"/>
-                <a:ea typeface="Oswald" pitchFamily="34" charset="-122"/>
-                <a:cs typeface="Oswald" pitchFamily="34" charset="-120"/>
+                <a:latin typeface="Arial" pitchFamily="34" charset="0"/>
+                <a:ea typeface="Arial" pitchFamily="34" charset="-122"/>
+                <a:cs typeface="Arial" pitchFamily="34" charset="-120"/>
               </a:rPr>
               <a:t>The simulator: test on a computer first</a:t>
             </a:r>
@@ -3008,9 +3008,9 @@
                 <a:solidFill>
                   <a:srgbClr val="15232B"/>
                 </a:solidFill>
-                <a:latin typeface="Oswald" pitchFamily="34" charset="0"/>
-                <a:ea typeface="Oswald" pitchFamily="34" charset="-122"/>
-                <a:cs typeface="Oswald" pitchFamily="34" charset="-120"/>
+                <a:latin typeface="Arial" pitchFamily="34" charset="0"/>
+                <a:ea typeface="Arial" pitchFamily="34" charset="-122"/>
+                <a:cs typeface="Arial" pitchFamily="34" charset="-120"/>
               </a:rPr>
               <a:t>Design your rover for the software</a:t>
             </a:r>
@@ -3590,9 +3590,9 @@
                 <a:solidFill>
                   <a:srgbClr val="15232B"/>
                 </a:solidFill>
-                <a:latin typeface="Oswald" pitchFamily="34" charset="0"/>
-                <a:ea typeface="Oswald" pitchFamily="34" charset="-122"/>
-                <a:cs typeface="Oswald" pitchFamily="34" charset="-120"/>
+                <a:latin typeface="Arial" pitchFamily="34" charset="0"/>
+                <a:ea typeface="Arial" pitchFamily="34" charset="-122"/>
+                <a:cs typeface="Arial" pitchFamily="34" charset="-120"/>
               </a:rPr>
               <a:t>Your first hour, in six steps</a:t>
             </a:r>
@@ -3656,9 +3656,9 @@
                 <a:solidFill>
                   <a:srgbClr val="B4531A"/>
                 </a:solidFill>
-                <a:latin typeface="Oswald" pitchFamily="34" charset="0"/>
-                <a:ea typeface="Oswald" pitchFamily="34" charset="-122"/>
-                <a:cs typeface="Oswald" pitchFamily="34" charset="-120"/>
+                <a:latin typeface="Arial" pitchFamily="34" charset="0"/>
+                <a:ea typeface="Arial" pitchFamily="34" charset="-122"/>
+                <a:cs typeface="Arial" pitchFamily="34" charset="-120"/>
               </a:rPr>
               <a:t>1</a:t>
             </a:r>
@@ -3766,9 +3766,9 @@
                 <a:solidFill>
                   <a:srgbClr val="B4531A"/>
                 </a:solidFill>
-                <a:latin typeface="Oswald" pitchFamily="34" charset="0"/>
-                <a:ea typeface="Oswald" pitchFamily="34" charset="-122"/>
-                <a:cs typeface="Oswald" pitchFamily="34" charset="-120"/>
+                <a:latin typeface="Arial" pitchFamily="34" charset="0"/>
+                <a:ea typeface="Arial" pitchFamily="34" charset="-122"/>
+                <a:cs typeface="Arial" pitchFamily="34" charset="-120"/>
               </a:rPr>
               <a:t>2</a:t>
             </a:r>
@@ -3876,9 +3876,9 @@
                 <a:solidFill>
                   <a:srgbClr val="B4531A"/>
                 </a:solidFill>
-                <a:latin typeface="Oswald" pitchFamily="34" charset="0"/>
-                <a:ea typeface="Oswald" pitchFamily="34" charset="-122"/>
-                <a:cs typeface="Oswald" pitchFamily="34" charset="-120"/>
+                <a:latin typeface="Arial" pitchFamily="34" charset="0"/>
+                <a:ea typeface="Arial" pitchFamily="34" charset="-122"/>
+                <a:cs typeface="Arial" pitchFamily="34" charset="-120"/>
               </a:rPr>
               <a:t>3</a:t>
             </a:r>
@@ -3986,9 +3986,9 @@
                 <a:solidFill>
                   <a:srgbClr val="B4531A"/>
                 </a:solidFill>
-                <a:latin typeface="Oswald" pitchFamily="34" charset="0"/>
-                <a:ea typeface="Oswald" pitchFamily="34" charset="-122"/>
-                <a:cs typeface="Oswald" pitchFamily="34" charset="-120"/>
+                <a:latin typeface="Arial" pitchFamily="34" charset="0"/>
+                <a:ea typeface="Arial" pitchFamily="34" charset="-122"/>
+                <a:cs typeface="Arial" pitchFamily="34" charset="-120"/>
               </a:rPr>
               <a:t>4</a:t>
             </a:r>
@@ -4096,9 +4096,9 @@
                 <a:solidFill>
                   <a:srgbClr val="B4531A"/>
                 </a:solidFill>
-                <a:latin typeface="Oswald" pitchFamily="34" charset="0"/>
-                <a:ea typeface="Oswald" pitchFamily="34" charset="-122"/>
-                <a:cs typeface="Oswald" pitchFamily="34" charset="-120"/>
+                <a:latin typeface="Arial" pitchFamily="34" charset="0"/>
+                <a:ea typeface="Arial" pitchFamily="34" charset="-122"/>
+                <a:cs typeface="Arial" pitchFamily="34" charset="-120"/>
               </a:rPr>
               <a:t>5</a:t>
             </a:r>
@@ -4206,9 +4206,9 @@
                 <a:solidFill>
                   <a:srgbClr val="B4531A"/>
                 </a:solidFill>
-                <a:latin typeface="Oswald" pitchFamily="34" charset="0"/>
-                <a:ea typeface="Oswald" pitchFamily="34" charset="-122"/>
-                <a:cs typeface="Oswald" pitchFamily="34" charset="-120"/>
+                <a:latin typeface="Arial" pitchFamily="34" charset="0"/>
+                <a:ea typeface="Arial" pitchFamily="34" charset="-122"/>
+                <a:cs typeface="Arial" pitchFamily="34" charset="-120"/>
               </a:rPr>
               <a:t>6</a:t>
             </a:r>
@@ -4416,9 +4416,9 @@
                 <a:solidFill>
                   <a:srgbClr val="15232B"/>
                 </a:solidFill>
-                <a:latin typeface="Oswald" pitchFamily="34" charset="0"/>
-                <a:ea typeface="Oswald" pitchFamily="34" charset="-122"/>
-                <a:cs typeface="Oswald" pitchFamily="34" charset="-120"/>
+                <a:latin typeface="Arial" pitchFamily="34" charset="0"/>
+                <a:ea typeface="Arial" pitchFamily="34" charset="-122"/>
+                <a:cs typeface="Arial" pitchFamily="34" charset="-120"/>
               </a:rPr>
               <a:t>Start with three places</a:t>
             </a:r>
@@ -5164,9 +5164,9 @@
                 <a:solidFill>
                   <a:srgbClr val="F5F2EA"/>
                 </a:solidFill>
-                <a:latin typeface="Oswald" pitchFamily="34" charset="0"/>
-                <a:ea typeface="Oswald" pitchFamily="34" charset="-122"/>
-                <a:cs typeface="Oswald" pitchFamily="34" charset="-120"/>
+                <a:latin typeface="Arial" pitchFamily="34" charset="0"/>
+                <a:ea typeface="Arial" pitchFamily="34" charset="-122"/>
+                <a:cs typeface="Arial" pitchFamily="34" charset="-120"/>
               </a:rPr>
               <a:t>MEASURE.</a:t>
             </a:r>
@@ -5184,9 +5184,9 @@
                 <a:solidFill>
                   <a:srgbClr val="F5F2EA"/>
                 </a:solidFill>
-                <a:latin typeface="Oswald" pitchFamily="34" charset="0"/>
-                <a:ea typeface="Oswald" pitchFamily="34" charset="-122"/>
-                <a:cs typeface="Oswald" pitchFamily="34" charset="-120"/>
+                <a:latin typeface="Arial" pitchFamily="34" charset="0"/>
+                <a:ea typeface="Arial" pitchFamily="34" charset="-122"/>
+                <a:cs typeface="Arial" pitchFamily="34" charset="-120"/>
               </a:rPr>
               <a:t>SIMULATE.</a:t>
             </a:r>
@@ -5204,9 +5204,9 @@
                 <a:solidFill>
                   <a:srgbClr val="F5F2EA"/>
                 </a:solidFill>
-                <a:latin typeface="Oswald" pitchFamily="34" charset="0"/>
-                <a:ea typeface="Oswald" pitchFamily="34" charset="-122"/>
-                <a:cs typeface="Oswald" pitchFamily="34" charset="-120"/>
+                <a:latin typeface="Arial" pitchFamily="34" charset="0"/>
+                <a:ea typeface="Arial" pitchFamily="34" charset="-122"/>
+                <a:cs typeface="Arial" pitchFamily="34" charset="-120"/>
               </a:rPr>
               <a:t>THEN DRIVE.</a:t>
             </a:r>
@@ -5370,9 +5370,9 @@
                 <a:solidFill>
                   <a:srgbClr val="15232B"/>
                 </a:solidFill>
-                <a:latin typeface="Oswald" pitchFamily="34" charset="0"/>
-                <a:ea typeface="Oswald" pitchFamily="34" charset="-122"/>
-                <a:cs typeface="Oswald" pitchFamily="34" charset="-120"/>
+                <a:latin typeface="Arial" pitchFamily="34" charset="0"/>
+                <a:ea typeface="Arial" pitchFamily="34" charset="-122"/>
+                <a:cs typeface="Arial" pitchFamily="34" charset="-120"/>
               </a:rPr>
               <a:t>One base, two brains to add on</a:t>
             </a:r>
@@ -5937,9 +5937,9 @@
                 <a:solidFill>
                   <a:srgbClr val="15232B"/>
                 </a:solidFill>
-                <a:latin typeface="Oswald" pitchFamily="34" charset="0"/>
-                <a:ea typeface="Oswald" pitchFamily="34" charset="-122"/>
-                <a:cs typeface="Oswald" pitchFamily="34" charset="-120"/>
+                <a:latin typeface="Arial" pitchFamily="34" charset="0"/>
+                <a:ea typeface="Arial" pitchFamily="34" charset="-122"/>
+                <a:cs typeface="Arial" pitchFamily="34" charset="-120"/>
               </a:rPr>
               <a:t>The three packages side by side</a:t>
             </a:r>
@@ -8386,9 +8386,9 @@
                 <a:solidFill>
                   <a:srgbClr val="15232B"/>
                 </a:solidFill>
-                <a:latin typeface="Oswald" pitchFamily="34" charset="0"/>
-                <a:ea typeface="Oswald" pitchFamily="34" charset="-122"/>
-                <a:cs typeface="Oswald" pitchFamily="34" charset="-120"/>
+                <a:latin typeface="Arial" pitchFamily="34" charset="0"/>
+                <a:ea typeface="Arial" pitchFamily="34" charset="-122"/>
+                <a:cs typeface="Arial" pitchFamily="34" charset="-120"/>
               </a:rPr>
               <a:t>You plan the route, it drives it accurately</a:t>
             </a:r>
@@ -8984,9 +8984,9 @@
                 <a:solidFill>
                   <a:srgbClr val="15232B"/>
                 </a:solidFill>
-                <a:latin typeface="Oswald" pitchFamily="34" charset="0"/>
-                <a:ea typeface="Oswald" pitchFamily="34" charset="-122"/>
-                <a:cs typeface="Oswald" pitchFamily="34" charset="-120"/>
+                <a:latin typeface="Arial" pitchFamily="34" charset="0"/>
+                <a:ea typeface="Arial" pitchFamily="34" charset="-122"/>
+                <a:cs typeface="Arial" pitchFamily="34" charset="-120"/>
               </a:rPr>
               <a:t>One hand on the wall, all the way round</a:t>
             </a:r>
@@ -9507,9 +9507,9 @@
                 <a:solidFill>
                   <a:srgbClr val="15232B"/>
                 </a:solidFill>
-                <a:latin typeface="Oswald" pitchFamily="34" charset="0"/>
-                <a:ea typeface="Oswald" pitchFamily="34" charset="-122"/>
-                <a:cs typeface="Oswald" pitchFamily="34" charset="-120"/>
+                <a:latin typeface="Arial" pitchFamily="34" charset="0"/>
+                <a:ea typeface="Arial" pitchFamily="34" charset="-122"/>
+                <a:cs typeface="Arial" pitchFamily="34" charset="-120"/>
               </a:rPr>
               <a:t>It maps the course and searches all of it</a:t>
             </a:r>
@@ -10065,9 +10065,9 @@
                 <a:solidFill>
                   <a:srgbClr val="15232B"/>
                 </a:solidFill>
-                <a:latin typeface="Oswald" pitchFamily="34" charset="0"/>
-                <a:ea typeface="Oswald" pitchFamily="34" charset="-122"/>
-                <a:cs typeface="Oswald" pitchFamily="34" charset="-120"/>
+                <a:latin typeface="Arial" pitchFamily="34" charset="0"/>
+                <a:ea typeface="Arial" pitchFamily="34" charset="-122"/>
+                <a:cs typeface="Arial" pitchFamily="34" charset="-120"/>
               </a:rPr>
               <a:t>Same course, three ways round</a:t>
             </a:r>
@@ -10476,9 +10476,9 @@
                 <a:solidFill>
                   <a:srgbClr val="15232B"/>
                 </a:solidFill>
-                <a:latin typeface="Oswald" pitchFamily="34" charset="0"/>
-                <a:ea typeface="Oswald" pitchFamily="34" charset="-122"/>
-                <a:cs typeface="Oswald" pitchFamily="34" charset="-120"/>
+                <a:latin typeface="Arial" pitchFamily="34" charset="0"/>
+                <a:ea typeface="Arial" pitchFamily="34" charset="-122"/>
+                <a:cs typeface="Arial" pitchFamily="34" charset="-120"/>
               </a:rPr>
               <a:t>Which one suits your team?</a:t>
             </a:r>
@@ -10999,9 +10999,9 @@
                 <a:solidFill>
                   <a:srgbClr val="F5F2EA"/>
                 </a:solidFill>
-                <a:latin typeface="Oswald" pitchFamily="34" charset="0"/>
-                <a:ea typeface="Oswald" pitchFamily="34" charset="-122"/>
-                <a:cs typeface="Oswald" pitchFamily="34" charset="-120"/>
+                <a:latin typeface="Arial" pitchFamily="34" charset="0"/>
+                <a:ea typeface="Arial" pitchFamily="34" charset="-122"/>
+                <a:cs typeface="Arial" pitchFamily="34" charset="-120"/>
               </a:rPr>
               <a:t>Every package comes with</a:t>
             </a:r>

</xml_diff>